<commit_message>
reorganized the summary figure
</commit_message>
<xml_diff>
--- a/contents/slides_sharing/figures.pptx
+++ b/contents/slides_sharing/figures.pptx
@@ -3390,7 +3390,7 @@
         </p:blipFill>
         <p:spPr>
           <a:xfrm>
-            <a:off x="2148087" y="1205493"/>
+            <a:off x="1998676" y="4130717"/>
             <a:ext cx="486918" cy="486918"/>
           </a:xfrm>
           <a:prstGeom prst="rect">
@@ -3426,7 +3426,7 @@
         </p:blipFill>
         <p:spPr>
           <a:xfrm>
-            <a:off x="1344338" y="3637305"/>
+            <a:off x="1204043" y="3214261"/>
             <a:ext cx="506818" cy="509656"/>
           </a:xfrm>
           <a:prstGeom prst="rect">
@@ -3498,7 +3498,7 @@
         </p:blipFill>
         <p:spPr>
           <a:xfrm>
-            <a:off x="1249707" y="1186762"/>
+            <a:off x="1225406" y="4130717"/>
             <a:ext cx="486918" cy="486918"/>
           </a:xfrm>
           <a:prstGeom prst="rect">
@@ -3581,7 +3581,7 @@
         </p:blipFill>
         <p:spPr>
           <a:xfrm>
-            <a:off x="1696707" y="1186762"/>
+            <a:off x="1612041" y="4130717"/>
             <a:ext cx="486918" cy="486918"/>
           </a:xfrm>
           <a:prstGeom prst="rect">
@@ -3639,7 +3639,7 @@
         </p:nvSpPr>
         <p:spPr>
           <a:xfrm>
-            <a:off x="1202228" y="2627314"/>
+            <a:off x="1061933" y="2204270"/>
             <a:ext cx="3361496" cy="338554"/>
           </a:xfrm>
           <a:prstGeom prst="rect">
@@ -3665,141 +3665,6 @@
           </a:p>
         </p:txBody>
       </p:sp>
-      <p:cxnSp>
-        <p:nvCxnSpPr>
-          <p:cNvPr id="31" name="Straight Arrow Connector 30">
-            <a:extLst>
-              <a:ext uri="{FF2B5EF4-FFF2-40B4-BE49-F238E27FC236}">
-                <a16:creationId xmlns:a16="http://schemas.microsoft.com/office/drawing/2014/main" id="{03DE7378-2B51-6E5D-3DEC-3499A4C9AAEE}"/>
-              </a:ext>
-            </a:extLst>
-          </p:cNvPr>
-          <p:cNvCxnSpPr>
-            <a:cxnSpLocks/>
-            <a:stCxn id="13" idx="2"/>
-          </p:cNvCxnSpPr>
-          <p:nvPr/>
-        </p:nvCxnSpPr>
-        <p:spPr>
-          <a:xfrm>
-            <a:off x="1940166" y="1673680"/>
-            <a:ext cx="0" cy="930175"/>
-          </a:xfrm>
-          <a:prstGeom prst="straightConnector1">
-            <a:avLst/>
-          </a:prstGeom>
-          <a:ln>
-            <a:solidFill>
-              <a:srgbClr val="7CA023"/>
-            </a:solidFill>
-            <a:tailEnd type="triangle"/>
-          </a:ln>
-        </p:spPr>
-        <p:style>
-          <a:lnRef idx="2">
-            <a:schemeClr val="accent1"/>
-          </a:lnRef>
-          <a:fillRef idx="0">
-            <a:schemeClr val="accent1"/>
-          </a:fillRef>
-          <a:effectRef idx="1">
-            <a:schemeClr val="accent1"/>
-          </a:effectRef>
-          <a:fontRef idx="minor">
-            <a:schemeClr val="tx1"/>
-          </a:fontRef>
-        </p:style>
-      </p:cxnSp>
-      <p:cxnSp>
-        <p:nvCxnSpPr>
-          <p:cNvPr id="34" name="Straight Arrow Connector 33">
-            <a:extLst>
-              <a:ext uri="{FF2B5EF4-FFF2-40B4-BE49-F238E27FC236}">
-                <a16:creationId xmlns:a16="http://schemas.microsoft.com/office/drawing/2014/main" id="{28A6506A-0F3A-35C8-8A80-F8C290C42468}"/>
-              </a:ext>
-            </a:extLst>
-          </p:cNvPr>
-          <p:cNvCxnSpPr>
-            <a:cxnSpLocks/>
-            <a:stCxn id="12" idx="2"/>
-          </p:cNvCxnSpPr>
-          <p:nvPr/>
-        </p:nvCxnSpPr>
-        <p:spPr>
-          <a:xfrm>
-            <a:off x="1493166" y="1673680"/>
-            <a:ext cx="243459" cy="930175"/>
-          </a:xfrm>
-          <a:prstGeom prst="straightConnector1">
-            <a:avLst/>
-          </a:prstGeom>
-          <a:ln>
-            <a:solidFill>
-              <a:srgbClr val="7CA023"/>
-            </a:solidFill>
-            <a:tailEnd type="triangle"/>
-          </a:ln>
-        </p:spPr>
-        <p:style>
-          <a:lnRef idx="2">
-            <a:schemeClr val="accent1"/>
-          </a:lnRef>
-          <a:fillRef idx="0">
-            <a:schemeClr val="accent1"/>
-          </a:fillRef>
-          <a:effectRef idx="1">
-            <a:schemeClr val="accent1"/>
-          </a:effectRef>
-          <a:fontRef idx="minor">
-            <a:schemeClr val="tx1"/>
-          </a:fontRef>
-        </p:style>
-      </p:cxnSp>
-      <p:cxnSp>
-        <p:nvCxnSpPr>
-          <p:cNvPr id="35" name="Straight Arrow Connector 34">
-            <a:extLst>
-              <a:ext uri="{FF2B5EF4-FFF2-40B4-BE49-F238E27FC236}">
-                <a16:creationId xmlns:a16="http://schemas.microsoft.com/office/drawing/2014/main" id="{308A3C88-8FF6-46F2-E3A8-3BC408561F36}"/>
-              </a:ext>
-            </a:extLst>
-          </p:cNvPr>
-          <p:cNvCxnSpPr>
-            <a:cxnSpLocks/>
-            <a:stCxn id="7" idx="2"/>
-          </p:cNvCxnSpPr>
-          <p:nvPr/>
-        </p:nvCxnSpPr>
-        <p:spPr>
-          <a:xfrm flipH="1">
-            <a:off x="2137886" y="1692411"/>
-            <a:ext cx="253660" cy="911444"/>
-          </a:xfrm>
-          <a:prstGeom prst="straightConnector1">
-            <a:avLst/>
-          </a:prstGeom>
-          <a:ln>
-            <a:solidFill>
-              <a:srgbClr val="7CA023"/>
-            </a:solidFill>
-            <a:tailEnd type="triangle"/>
-          </a:ln>
-        </p:spPr>
-        <p:style>
-          <a:lnRef idx="2">
-            <a:schemeClr val="accent1"/>
-          </a:lnRef>
-          <a:fillRef idx="0">
-            <a:schemeClr val="accent1"/>
-          </a:fillRef>
-          <a:effectRef idx="1">
-            <a:schemeClr val="accent1"/>
-          </a:effectRef>
-          <a:fontRef idx="minor">
-            <a:schemeClr val="tx1"/>
-          </a:fontRef>
-        </p:style>
-      </p:cxnSp>
       <p:pic>
         <p:nvPicPr>
           <p:cNvPr id="58" name="Graphic 57" descr="Filing Box Archive with solid fill">
@@ -3828,7 +3693,7 @@
         </p:blipFill>
         <p:spPr>
           <a:xfrm>
-            <a:off x="1316952" y="2900808"/>
+            <a:off x="1176657" y="2477764"/>
             <a:ext cx="518144" cy="518144"/>
           </a:xfrm>
           <a:prstGeom prst="rect">
@@ -3886,7 +3751,7 @@
         </p:nvSpPr>
         <p:spPr>
           <a:xfrm>
-            <a:off x="1804196" y="2869151"/>
+            <a:off x="1663901" y="2446107"/>
             <a:ext cx="2880775" cy="1384995"/>
           </a:xfrm>
           <a:prstGeom prst="rect">
@@ -4030,7 +3895,7 @@
         </p:nvSpPr>
         <p:spPr>
           <a:xfrm>
-            <a:off x="1134657" y="665681"/>
+            <a:off x="2485594" y="4112566"/>
             <a:ext cx="2579219" cy="523220"/>
           </a:xfrm>
           <a:prstGeom prst="rect">
@@ -4062,7 +3927,7 @@
                 </a:solidFill>
                 <a:latin typeface="+mj-lt"/>
               </a:rPr>
-              <a:t>Reference to code DOI</a:t>
+              <a:t>Citing the DOI entry with code</a:t>
             </a:r>
             <a:endParaRPr lang="en-US" sz="1400" b="1" dirty="0">
               <a:solidFill>
@@ -4087,7 +3952,7 @@
         </p:nvGrpSpPr>
         <p:grpSpPr>
           <a:xfrm>
-            <a:off x="1308740" y="4818398"/>
+            <a:off x="1061933" y="913878"/>
             <a:ext cx="3501791" cy="951838"/>
             <a:chOff x="1377268" y="4394316"/>
             <a:chExt cx="3501791" cy="951838"/>
@@ -4161,8 +4026,8 @@
           </p:blipFill>
           <p:spPr>
             <a:xfrm>
-              <a:off x="1478186" y="4732870"/>
-              <a:ext cx="515182" cy="515180"/>
+              <a:off x="1478186" y="4796412"/>
+              <a:ext cx="451640" cy="451638"/>
             </a:xfrm>
             <a:prstGeom prst="rect">
               <a:avLst/>
@@ -4259,9 +4124,9 @@
           <p:nvPr/>
         </p:nvCxnSpPr>
         <p:spPr>
-          <a:xfrm flipV="1">
-            <a:off x="1956282" y="4322635"/>
-            <a:ext cx="0" cy="497071"/>
+          <a:xfrm>
+            <a:off x="1422242" y="1733567"/>
+            <a:ext cx="0" cy="470703"/>
           </a:xfrm>
           <a:prstGeom prst="straightConnector1">
             <a:avLst/>
@@ -4270,6 +4135,52 @@
             <a:solidFill>
               <a:srgbClr val="7CA023"/>
             </a:solidFill>
+            <a:prstDash val="sysDash"/>
+            <a:tailEnd type="triangle"/>
+          </a:ln>
+        </p:spPr>
+        <p:style>
+          <a:lnRef idx="2">
+            <a:schemeClr val="accent1"/>
+          </a:lnRef>
+          <a:fillRef idx="0">
+            <a:schemeClr val="accent1"/>
+          </a:fillRef>
+          <a:effectRef idx="1">
+            <a:schemeClr val="accent1"/>
+          </a:effectRef>
+          <a:fontRef idx="minor">
+            <a:schemeClr val="tx1"/>
+          </a:fontRef>
+        </p:style>
+      </p:cxnSp>
+      <p:cxnSp>
+        <p:nvCxnSpPr>
+          <p:cNvPr id="6" name="Straight Arrow Connector 5">
+            <a:extLst>
+              <a:ext uri="{FF2B5EF4-FFF2-40B4-BE49-F238E27FC236}">
+                <a16:creationId xmlns:a16="http://schemas.microsoft.com/office/drawing/2014/main" id="{69261312-83AE-75C5-77F0-EB2899F53410}"/>
+              </a:ext>
+            </a:extLst>
+          </p:cNvPr>
+          <p:cNvCxnSpPr>
+            <a:cxnSpLocks/>
+          </p:cNvCxnSpPr>
+          <p:nvPr/>
+        </p:nvCxnSpPr>
+        <p:spPr>
+          <a:xfrm>
+            <a:off x="1422242" y="3750525"/>
+            <a:ext cx="0" cy="316650"/>
+          </a:xfrm>
+          <a:prstGeom prst="straightConnector1">
+            <a:avLst/>
+          </a:prstGeom>
+          <a:ln>
+            <a:solidFill>
+              <a:srgbClr val="7CA023"/>
+            </a:solidFill>
+            <a:prstDash val="sysDash"/>
             <a:tailEnd type="triangle"/>
           </a:ln>
         </p:spPr>

</xml_diff>